<commit_message>
fix(pages): eliminate 404/405 errors on GitHub Pages with in-browser NLP and bundled demo audio
</commit_message>
<xml_diff>
--- a/presentation/Kural AI - PPT.pptx
+++ b/presentation/Kural AI - PPT.pptx
@@ -1977,7 +1977,7 @@
                 <a:ea typeface="Calibri" pitchFamily="34" charset="-122"/>
                 <a:cs typeface="Calibri" pitchFamily="34" charset="-120"/>
               </a:rPr>
-              <a:t>RA231003040045</a:t>
+              <a:t>RA2311003040045</a:t>
             </a:r>
             <a:endParaRPr lang="en-US" sz="1400" dirty="0"/>
           </a:p>
@@ -2019,7 +2019,7 @@
                 <a:ea typeface="Calibri" pitchFamily="34" charset="-122"/>
                 <a:cs typeface="Calibri" pitchFamily="34" charset="-120"/>
               </a:rPr>
-              <a:t>Jai Vignesh B
+              <a:t>Jai Vignesh K
 </a:t>
             </a:r>
             <a:r>
@@ -2031,7 +2031,7 @@
                 <a:ea typeface="Calibri" pitchFamily="34" charset="-122"/>
                 <a:cs typeface="Calibri" pitchFamily="34" charset="-120"/>
               </a:rPr>
-              <a:t>RA231003040020</a:t>
+              <a:t>RA2311003040020</a:t>
             </a:r>
             <a:endParaRPr lang="en-US" sz="1400" dirty="0"/>
           </a:p>

</xml_diff>